<commit_message>
docs: clear the last two stale figures
The deck had '95 engine tests' hardcoded on a slide; it now reads
F.counts.tests from figures.json like every other number, and names the
four suites rather than describing the old three.

docs/methodology.md still derived 179.13 kWh_th/m3 from an ASSUMED steam
economy of 3.5. Steam economy is now anchored on the published 0.25-0.35
kg steam per kg evaporated, giving 3.333 and 188.08 kWh_th/m3, with the
reasoning for not taking the flattering end of the range written down.

Co-Authored-By: Claude Opus 5 <noreply@anthropic.com>
</commit_message>
<xml_diff>
--- a/submission/ChangeLoop_SANKALP_2026.pptx
+++ b/submission/ChangeLoop_SANKALP_2026.pptx
@@ -121,57 +121,57 @@
   <p:extLst>
     <p:ext uri="{521415D9-36F7-43E2-AB2F-B90AF26B5E84}">
       <p14:sectionLst xmlns:p14="http://schemas.microsoft.com/office/powerpoint/2010/main">
-        <p14:section name="Opening" id="{b8e1a6ff-9810-f74d-8102-7848af884533}">
+        <p14:section name="Opening" id="{cd3835f4-2b97-cd55-8fc8-7946bdf64f0e}">
           <p14:sldIdLst>
             <p14:sldId id="256"/>
           </p14:sldIdLst>
         </p14:section>
-        <p14:section name="Summary" id="{f0dd3373-f5ea-6c31-566c-15769a9ae9e6}">
+        <p14:section name="Summary" id="{154d3e0e-a07b-322b-12d0-a13ec1226d76}">
           <p14:sldIdLst>
             <p14:sldId id="257"/>
           </p14:sldIdLst>
         </p14:section>
-        <p14:section name="Problem" id="{4951a4b1-4b11-d55a-99d1-a29ea8e0fbd2}">
+        <p14:section name="Problem" id="{aa5b9e3c-c71b-9032-a902-4f6e3ecf1e80}">
           <p14:sldIdLst>
             <p14:sldId id="258"/>
             <p14:sldId id="259"/>
           </p14:sldIdLst>
         </p14:section>
-        <p14:section name="Insight" id="{6f82cd58-c86c-73ff-6e35-9a7a2c0d5e73}">
+        <p14:section name="Insight" id="{5ae240c7-3b37-4ed9-079c-305a3218955e}">
           <p14:sldIdLst>
             <p14:sldId id="260"/>
           </p14:sldIdLst>
         </p14:section>
-        <p14:section name="Solution" id="{06af25dc-e027-674e-7c1f-8a37ebdfe3f6}">
+        <p14:section name="Solution" id="{1cda6104-b4e4-b76e-ee57-3ea51fe4e278}">
           <p14:sldIdLst>
             <p14:sldId id="261"/>
           </p14:sldIdLst>
         </p14:section>
-        <p14:section name="Innovation" id="{fe1e12fd-4e1d-9a36-3e4c-370aac597b54}">
+        <p14:section name="Innovation" id="{d94f8c09-dca5-4c09-3332-6ccaf4ae7545}">
           <p14:sldIdLst>
             <p14:sldId id="262"/>
           </p14:sldIdLst>
         </p14:section>
-        <p14:section name="Product" id="{0a23c684-17c9-210c-2d3f-b5c8f8f8ff8e}">
+        <p14:section name="Product" id="{e572859a-5a4f-6295-fc83-b38efb6f74ff}">
           <p14:sldIdLst>
             <p14:sldId id="263"/>
             <p14:sldId id="264"/>
           </p14:sldIdLst>
         </p14:section>
-        <p14:section name="Impact" id="{b4b24d83-947f-c608-852f-dc0d624a31e1}">
+        <p14:section name="Impact" id="{c41b93e5-0c3f-52ba-c50c-de2de8f320ab}">
           <p14:sldIdLst>
             <p14:sldId id="265"/>
             <p14:sldId id="266"/>
           </p14:sldIdLst>
         </p14:section>
-        <p14:section name="Path" id="{1ed9f264-077b-54e2-7d15-3e2473ccf947}">
+        <p14:section name="Path" id="{0090334c-2008-a131-e02d-b1a0e381b7a0}">
           <p14:sldIdLst>
             <p14:sldId id="267"/>
             <p14:sldId id="268"/>
             <p14:sldId id="269"/>
           </p14:sldIdLst>
         </p14:section>
-        <p14:section name="Team" id="{8c281f97-4ced-bb1c-e7e3-93bb3fa2e738}">
+        <p14:section name="Team" id="{072e6817-d026-9154-d557-e9b0fbc0904d}">
           <p14:sldIdLst>
             <p14:sldId id="270"/>
           </p14:sldIdLst>
@@ -13216,7 +13216,7 @@
                   <a:srgbClr val="4ECF9E"/>
                 </a:solidFill>
               </a:rPr>
-              <a:t>95 engine tests</a:t>
+              <a:t>140 automated tests</a:t>
             </a:r>
             <a:pPr indent="0" marL="0">
               <a:buNone/>
@@ -13227,7 +13227,7 @@
                   <a:srgbClr val="B7CBD0"/>
                 </a:solidFill>
               </a:rPr>
-              <a:t>, a golden-path suite, safety-interlock tests across five fault modes, a ten-run determinism check, and a tamper test that breaks the ledger chain on purpose to prove it detects it.
+              <a:t> across 4 suites: the engine, cross-validation against published plant data, registry concurrency, safety interlocks over five fault modes, a determinism check, and a tamper test that breaks the ledger chain on purpose to prove it detects it.
 </a:t>
             </a:r>
             <a:pPr indent="0" marL="0">

</xml_diff>

<commit_message>
fix(deck): the team slide contradicted the deck it was in
Two faults on slide 15, found on a final read of the renders.

It stated '95 engine tests' while slide 13, in the same deck, stated 140.
A reviewer who notices that stops trusting both numbers, and they would
be right to. It now reads F.counts.tests like every other figure, so the
two slides cannot disagree again, and it names the four suites rather
than describing the three that existed when the sentence was written.

The ask still said 'two measured numbers: steam cost per cubic metre of
reject, and the reject TDS ceiling' - written before the registry was
re-sourced, when those were two assumptions among thirteen. They are
now two instrument readings standing between a validated model and a
measured one, with everything else already sourced, which is both true
and a considerably stronger thing to ask for.

Deck validates, 140 tests pass, figures in sync, PDF re-exported.

Co-Authored-By: Claude Opus 5 <noreply@anthropic.com>
</commit_message>
<xml_diff>
--- a/submission/ChangeLoop_SANKALP_2026.pptx
+++ b/submission/ChangeLoop_SANKALP_2026.pptx
@@ -121,57 +121,57 @@
   <p:extLst>
     <p:ext uri="{521415D9-36F7-43E2-AB2F-B90AF26B5E84}">
       <p14:sectionLst xmlns:p14="http://schemas.microsoft.com/office/powerpoint/2010/main">
-        <p14:section name="Opening" id="{cd3835f4-2b97-cd55-8fc8-7946bdf64f0e}">
+        <p14:section name="Opening" id="{e087072d-af2d-2e9b-7a58-2debde40c0b1}">
           <p14:sldIdLst>
             <p14:sldId id="256"/>
           </p14:sldIdLst>
         </p14:section>
-        <p14:section name="Summary" id="{154d3e0e-a07b-322b-12d0-a13ec1226d76}">
+        <p14:section name="Summary" id="{ee1c9af7-0ca7-390f-7afd-9a6afc77317b}">
           <p14:sldIdLst>
             <p14:sldId id="257"/>
           </p14:sldIdLst>
         </p14:section>
-        <p14:section name="Problem" id="{aa5b9e3c-c71b-9032-a902-4f6e3ecf1e80}">
+        <p14:section name="Problem" id="{b2e75daa-cce1-bd61-a8b1-e6557eb00c2b}">
           <p14:sldIdLst>
             <p14:sldId id="258"/>
             <p14:sldId id="259"/>
           </p14:sldIdLst>
         </p14:section>
-        <p14:section name="Insight" id="{5ae240c7-3b37-4ed9-079c-305a3218955e}">
+        <p14:section name="Insight" id="{87c50d92-2d6a-c60c-3f49-4200444ca5b3}">
           <p14:sldIdLst>
             <p14:sldId id="260"/>
           </p14:sldIdLst>
         </p14:section>
-        <p14:section name="Solution" id="{1cda6104-b4e4-b76e-ee57-3ea51fe4e278}">
+        <p14:section name="Solution" id="{bbe45c93-bed2-50dd-d353-47910b92e246}">
           <p14:sldIdLst>
             <p14:sldId id="261"/>
           </p14:sldIdLst>
         </p14:section>
-        <p14:section name="Innovation" id="{d94f8c09-dca5-4c09-3332-6ccaf4ae7545}">
+        <p14:section name="Innovation" id="{307c11b0-b889-0275-83f6-8c0a8ee269fc}">
           <p14:sldIdLst>
             <p14:sldId id="262"/>
           </p14:sldIdLst>
         </p14:section>
-        <p14:section name="Product" id="{e572859a-5a4f-6295-fc83-b38efb6f74ff}">
+        <p14:section name="Product" id="{b738fe0a-df8d-2eae-c952-8ce69560ed9c}">
           <p14:sldIdLst>
             <p14:sldId id="263"/>
             <p14:sldId id="264"/>
           </p14:sldIdLst>
         </p14:section>
-        <p14:section name="Impact" id="{c41b93e5-0c3f-52ba-c50c-de2de8f320ab}">
+        <p14:section name="Impact" id="{a3f1d993-d08c-645f-153d-34dab13d3e7e}">
           <p14:sldIdLst>
             <p14:sldId id="265"/>
             <p14:sldId id="266"/>
           </p14:sldIdLst>
         </p14:section>
-        <p14:section name="Path" id="{0090334c-2008-a131-e02d-b1a0e381b7a0}">
+        <p14:section name="Path" id="{6bbe99e1-b040-72b8-bd9a-72adbdcc3894}">
           <p14:sldIdLst>
             <p14:sldId id="267"/>
             <p14:sldId id="268"/>
             <p14:sldId id="269"/>
           </p14:sldIdLst>
         </p14:section>
-        <p14:section name="Team" id="{072e6817-d026-9154-d557-e9b0fbc0904d}">
+        <p14:section name="Team" id="{9b9a7532-733f-bd0f-ea89-210998bea029}">
           <p14:sldIdLst>
             <p14:sldId id="270"/>
           </p14:sldIdLst>
@@ -13394,7 +13394,7 @@
                   <a:srgbClr val="B7CBD0"/>
                 </a:solidFill>
               </a:rPr>
-              <a:t>one Tirupur dyeing unit or CETP willing to share two measured numbers: steam cost per cubic metre of reject, and the reject TDS ceiling. Our own sensitivity sweep says those two decide the answer, and they are the first thing Phase 1 measures.</a:t>
+              <a:t>one Tirupur dyeing unit or CETP willing to share two instrument readings: steam flow to the evaporator, and reject conductivity. Everything else is already sourced from CPCB, the CEA, TNERC and pollution-board data — those two are all that separate a validated model from a measured one.</a:t>
             </a:r>
             <a:endParaRPr lang="en-US" sz="1200" dirty="0"/>
           </a:p>

</xml_diff>

<commit_message>
chore(submission): rebuild the deck on the current figures
Picks up the test count moving from 143 to 163 with the plant
coordination work. Deck validates clean.

Co-Authored-By: Claude Opus 5 <noreply@anthropic.com>
</commit_message>
<xml_diff>
--- a/submission/ChangeLoop_SANKALP_2026.pptx
+++ b/submission/ChangeLoop_SANKALP_2026.pptx
@@ -121,57 +121,57 @@
   <p:extLst>
     <p:ext uri="{521415D9-36F7-43E2-AB2F-B90AF26B5E84}">
       <p14:sectionLst xmlns:p14="http://schemas.microsoft.com/office/powerpoint/2010/main">
-        <p14:section name="Opening" id="{10ac7a95-df10-7d5e-59ad-95878923bdfb}">
+        <p14:section name="Opening" id="{6386af24-d665-9d2e-3e5a-f276a7e7d9a3}">
           <p14:sldIdLst>
             <p14:sldId id="256"/>
           </p14:sldIdLst>
         </p14:section>
-        <p14:section name="Summary" id="{81e7e102-912a-f81e-3476-70f729c9db0d}">
+        <p14:section name="Summary" id="{368b1603-8cc9-dd1c-06ac-f48f479e3236}">
           <p14:sldIdLst>
             <p14:sldId id="257"/>
           </p14:sldIdLst>
         </p14:section>
-        <p14:section name="Problem" id="{8cfdbaf8-5262-5976-b0eb-c6f95138bb7e}">
+        <p14:section name="Problem" id="{16e5367b-3183-c894-5424-4749e33ecfcc}">
           <p14:sldIdLst>
             <p14:sldId id="258"/>
             <p14:sldId id="259"/>
           </p14:sldIdLst>
         </p14:section>
-        <p14:section name="Insight" id="{8f21897b-1f1d-f5c2-c80b-bf3350ad98ae}">
+        <p14:section name="Insight" id="{1aba06ae-114c-a1aa-2246-376f51641f88}">
           <p14:sldIdLst>
             <p14:sldId id="260"/>
           </p14:sldIdLst>
         </p14:section>
-        <p14:section name="Solution" id="{b036496c-eec4-a40b-3b7d-529eee3c2241}">
+        <p14:section name="Solution" id="{aa678537-8fde-b4d1-ffeb-ca09d284ddee}">
           <p14:sldIdLst>
             <p14:sldId id="261"/>
           </p14:sldIdLst>
         </p14:section>
-        <p14:section name="Innovation" id="{8db3438d-a717-a920-4e64-9e6766cff76e}">
+        <p14:section name="Innovation" id="{b4ed75d2-c459-826f-d77c-05de0947bf71}">
           <p14:sldIdLst>
             <p14:sldId id="262"/>
           </p14:sldIdLst>
         </p14:section>
-        <p14:section name="Product" id="{2dd0687a-d128-cf8b-840e-862f3c55ea19}">
+        <p14:section name="Product" id="{3e24d67d-6b8d-bd6a-9965-c7dd9034a006}">
           <p14:sldIdLst>
             <p14:sldId id="263"/>
             <p14:sldId id="264"/>
           </p14:sldIdLst>
         </p14:section>
-        <p14:section name="Impact" id="{cb5af419-821d-08be-bc13-85e38fc73bbb}">
+        <p14:section name="Impact" id="{a4b43cf9-c5de-9a81-2142-e2df29a3edc7}">
           <p14:sldIdLst>
             <p14:sldId id="265"/>
             <p14:sldId id="266"/>
           </p14:sldIdLst>
         </p14:section>
-        <p14:section name="Path" id="{9b18a5bf-173d-4800-11a4-027cf2fae6cd}">
+        <p14:section name="Path" id="{e93d07af-c0db-0d7b-ee37-453b532021ad}">
           <p14:sldIdLst>
             <p14:sldId id="267"/>
             <p14:sldId id="268"/>
             <p14:sldId id="269"/>
           </p14:sldIdLst>
         </p14:section>
-        <p14:section name="Team" id="{a3b3aab2-1b48-d55e-c24c-b027da9f1b6f}">
+        <p14:section name="Team" id="{938a7cd8-6d9a-b3d3-ae75-b26e9f8e74fc}">
           <p14:sldIdLst>
             <p14:sldId id="270"/>
           </p14:sldIdLst>
@@ -10263,7 +10263,7 @@
                 <a:ea typeface="Cambria" pitchFamily="34" charset="-122"/>
                 <a:cs typeface="Cambria" pitchFamily="34" charset="-120"/>
               </a:rPr>
-              <a:t>143</a:t>
+              <a:t>163</a:t>
             </a:r>
             <a:endParaRPr lang="en-US" sz="3200" dirty="0"/>
           </a:p>
@@ -10388,7 +10388,7 @@
                 <a:ea typeface="Cambria" pitchFamily="34" charset="-122"/>
                 <a:cs typeface="Cambria" pitchFamily="34" charset="-120"/>
               </a:rPr>
-              <a:t>32</a:t>
+              <a:t>33</a:t>
             </a:r>
             <a:endParaRPr lang="en-US" sz="3200" dirty="0"/>
           </a:p>
@@ -13216,7 +13216,7 @@
                   <a:srgbClr val="4ECF9E"/>
                 </a:solidFill>
               </a:rPr>
-              <a:t>143 automated tests</a:t>
+              <a:t>163 automated tests</a:t>
             </a:r>
             <a:pPr indent="0" marL="0">
               <a:buNone/>
@@ -13227,7 +13227,7 @@
                   <a:srgbClr val="B7CBD0"/>
                 </a:solidFill>
               </a:rPr>
-              <a:t> across 4 suites: the engine, cross-validation against published plant data, registry concurrency, safety interlocks over five fault modes, a determinism check, and a tamper test that breaks the ledger chain on purpose to prove it detects it.
+              <a:t> across 5 suites: the engine, cross-validation against published plant data, registry concurrency, safety interlocks over five fault modes, a determinism check, and a tamper test that breaks the ledger chain on purpose to prove it detects it.
 </a:t>
             </a:r>
             <a:pPr indent="0" marL="0">

</xml_diff>